<commit_message>
Deck: situation slide matches what the labeller really does
Co-Authored-By: Claude Sonnet 5.5 <noreply@anthropic.com>
Claude-Session: https://claude.ai/code/session_0193BBUnvq5oXswYPohxuD5V
</commit_message>
<xml_diff>
--- a/docs/connect-iqoo-deck.pptx
+++ b/docs/connect-iqoo-deck.pptx
@@ -4236,7 +4236,7 @@
               </a:defRPr>
             </a:pPr>
             <a:r>
-              <a:t>Photograph the problem; the phone labels the scene and suggests the reason.</a:t>
+              <a:t>Photograph the problem; the phone labels the scene on-device.</a:t>
             </a:r>
           </a:p>
           <a:p>
@@ -4251,7 +4251,7 @@
               </a:defRPr>
             </a:pPr>
             <a:r>
-              <a:t>It drafts the message and flags urgent cases (accident, towing).</a:t>
+              <a:t>On a clear sign (a wreck, a tow truck, a gate in frame) it suggests the reason, drafts the message and flags urgency. Otherwise it leaves the choice to you.</a:t>
             </a:r>
           </a:p>
           <a:p>

</xml_diff>

<commit_message>
Deck: slide for our own ML model
</commit_message>
<xml_diff>
--- a/docs/connect-iqoo-deck.pptx
+++ b/docs/connect-iqoo-deck.pptx
@@ -15,6 +15,7 @@
     <p:sldId id="263" r:id="rId14"/>
     <p:sldId id="264" r:id="rId15"/>
     <p:sldId id="265" r:id="rId16"/>
+    <p:sldId id="266" r:id="rId17"/>
   </p:sldIdLst>
   <p:sldSz cx="12191695" cy="6858000" type="screen4x3"/>
   <p:notesSz cx="6858000" cy="9144000"/>
@@ -3264,6 +3265,211 @@
             <a:avLst/>
           </a:prstGeom>
           <a:solidFill>
+            <a:srgbClr val="EEEDF8"/>
+          </a:solidFill>
+          <a:ln>
+            <a:noFill/>
+          </a:ln>
+        </p:spPr>
+        <p:style>
+          <a:lnRef idx="1">
+            <a:schemeClr val="accent1"/>
+          </a:lnRef>
+          <a:fillRef idx="3">
+            <a:schemeClr val="accent1"/>
+          </a:fillRef>
+          <a:effectRef idx="2">
+            <a:schemeClr val="accent1"/>
+          </a:effectRef>
+          <a:fontRef idx="minor">
+            <a:schemeClr val="lt1"/>
+          </a:fontRef>
+        </p:style>
+        <p:txBody>
+          <a:bodyPr rtlCol="0" anchor="ctr"/>
+          <a:lstStyle/>
+          <a:p>
+            <a:pPr algn="ctr"/>
+          </a:p>
+        </p:txBody>
+      </p:sp>
+      <p:sp>
+        <p:nvSpPr>
+          <p:cNvPr id="3" name="TextBox 2"/>
+          <p:cNvSpPr txBox="1"/>
+          <p:nvPr/>
+        </p:nvSpPr>
+        <p:spPr>
+          <a:xfrm>
+            <a:off x="731520" y="548640"/>
+            <a:ext cx="10058400" cy="365760"/>
+          </a:xfrm>
+          <a:prstGeom prst="rect">
+            <a:avLst/>
+          </a:prstGeom>
+          <a:noFill/>
+        </p:spPr>
+        <p:txBody>
+          <a:bodyPr wrap="square">
+            <a:spAutoFit/>
+          </a:bodyPr>
+          <a:lstStyle/>
+          <a:p>
+            <a:pPr>
+              <a:spcAft>
+                <a:spcPts val="1000"/>
+              </a:spcAft>
+              <a:defRPr sz="1400" b="1">
+                <a:solidFill>
+                  <a:srgbClr val="5A45C9"/>
+                </a:solidFill>
+              </a:defRPr>
+            </a:pPr>
+            <a:r>
+              <a:t>PROOF</a:t>
+            </a:r>
+          </a:p>
+        </p:txBody>
+      </p:sp>
+      <p:sp>
+        <p:nvSpPr>
+          <p:cNvPr id="4" name="TextBox 3"/>
+          <p:cNvSpPr txBox="1"/>
+          <p:nvPr/>
+        </p:nvSpPr>
+        <p:spPr>
+          <a:xfrm>
+            <a:off x="731520" y="914400"/>
+            <a:ext cx="10698480" cy="1280160"/>
+          </a:xfrm>
+          <a:prstGeom prst="rect">
+            <a:avLst/>
+          </a:prstGeom>
+          <a:noFill/>
+        </p:spPr>
+        <p:txBody>
+          <a:bodyPr wrap="square">
+            <a:spAutoFit/>
+          </a:bodyPr>
+          <a:lstStyle/>
+          <a:p>
+            <a:pPr>
+              <a:spcAft>
+                <a:spcPts val="1000"/>
+              </a:spcAft>
+              <a:defRPr sz="4000" b="1">
+                <a:solidFill>
+                  <a:srgbClr val="171335"/>
+                </a:solidFill>
+              </a:defRPr>
+            </a:pPr>
+            <a:r>
+              <a:t>Free to run, tested to trust</a:t>
+            </a:r>
+          </a:p>
+        </p:txBody>
+      </p:sp>
+      <p:sp>
+        <p:nvSpPr>
+          <p:cNvPr id="5" name="TextBox 4"/>
+          <p:cNvSpPr txBox="1"/>
+          <p:nvPr/>
+        </p:nvSpPr>
+        <p:spPr>
+          <a:xfrm>
+            <a:off x="731520" y="2468880"/>
+            <a:ext cx="10515600" cy="3931920"/>
+          </a:xfrm>
+          <a:prstGeom prst="rect">
+            <a:avLst/>
+          </a:prstGeom>
+          <a:noFill/>
+        </p:spPr>
+        <p:txBody>
+          <a:bodyPr wrap="square">
+            <a:spAutoFit/>
+          </a:bodyPr>
+          <a:lstStyle/>
+          <a:p>
+            <a:pPr>
+              <a:spcAft>
+                <a:spcPts val="1000"/>
+              </a:spcAft>
+              <a:defRPr sz="2200" b="0">
+                <a:solidFill>
+                  <a:srgbClr val="575279"/>
+                </a:solidFill>
+              </a:defRPr>
+            </a:pPr>
+            <a:r>
+              <a:t>Rs 0 per month on free tiers (Supabase, FCM, Vercel).</a:t>
+            </a:r>
+          </a:p>
+          <a:p>
+            <a:pPr>
+              <a:spcAft>
+                <a:spcPts val="1000"/>
+              </a:spcAft>
+              <a:defRPr sz="2200" b="0">
+                <a:solidFill>
+                  <a:srgbClr val="575279"/>
+                </a:solidFill>
+              </a:defRPr>
+            </a:pPr>
+            <a:r>
+              <a:t>119 backend end-to-end checks and 49 app tests and 3 on-device ML checks; CI on every push.</a:t>
+            </a:r>
+          </a:p>
+          <a:p>
+            <a:pPr>
+              <a:spcAft>
+                <a:spcPts val="1000"/>
+              </a:spcAft>
+              <a:defRPr sz="2200" b="0">
+                <a:solidFill>
+                  <a:srgbClr val="575279"/>
+                </a:solidFill>
+              </a:defRPr>
+            </a:pPr>
+            <a:r>
+              <a:t>English, Hindi, Kannada and Tamil across the app, scan page and trip page.</a:t>
+            </a:r>
+          </a:p>
+        </p:txBody>
+      </p:sp>
+    </p:spTree>
+  </p:cSld>
+  <p:clrMapOvr>
+    <a:masterClrMapping/>
+  </p:clrMapOvr>
+</p:sld>
+</file>
+
+<file path=ppt/slides/slide11.xml><?xml version="1.0" encoding="utf-8"?>
+<p:sld xmlns:a="http://schemas.openxmlformats.org/drawingml/2006/main" xmlns:p="http://schemas.openxmlformats.org/presentationml/2006/main" xmlns:r="http://schemas.openxmlformats.org/officeDocument/2006/relationships">
+  <p:cSld>
+    <p:spTree>
+      <p:nvGrpSpPr>
+        <p:cNvPr id="1" name=""/>
+        <p:cNvGrpSpPr/>
+        <p:nvPr/>
+      </p:nvGrpSpPr>
+      <p:grpSpPr/>
+      <p:sp>
+        <p:nvSpPr>
+          <p:cNvPr id="2" name="Rectangle 1"/>
+          <p:cNvSpPr/>
+          <p:nvPr/>
+        </p:nvSpPr>
+        <p:spPr>
+          <a:xfrm>
+            <a:off x="0" y="0"/>
+            <a:ext cx="12191695" cy="6858000"/>
+          </a:xfrm>
+          <a:prstGeom prst="rect">
+            <a:avLst/>
+          </a:prstGeom>
+          <a:solidFill>
             <a:srgbClr val="171335"/>
           </a:solidFill>
           <a:ln>
@@ -4198,7 +4404,7 @@
               </a:defRPr>
             </a:pPr>
             <a:r>
-              <a:t>On-device AI: understand the situation</a:t>
+              <a:t>Our own ML model: a plate detector</a:t>
             </a:r>
           </a:p>
         </p:txBody>
@@ -4236,7 +4442,7 @@
               </a:defRPr>
             </a:pPr>
             <a:r>
-              <a:t>Photograph the problem; the phone labels the scene on-device.</a:t>
+              <a:t>YOLO11n we trained on 8,823 plate photos in 11 minutes on a laptop GPU. 2.6 M parameters, 10 MB, runs on the phone with ONNX Runtime.</a:t>
             </a:r>
           </a:p>
           <a:p>
@@ -4251,7 +4457,7 @@
               </a:defRPr>
             </a:pPr>
             <a:r>
-              <a:t>On a clear sign (a wreck, a tow truck, a gate in frame) it suggests the reason, drafts the message and flags urgency. Otherwise it leaves the choice to you.</a:t>
+              <a:t>Held-out test: mAP50 0.991, precision 0.992, recall 0.977 (882 photos). About 80-130 ms a frame on an emulator CPU.</a:t>
             </a:r>
           </a:p>
           <a:p>
@@ -4266,7 +4472,7 @@
               </a:defRPr>
             </a:pPr>
             <a:r>
-              <a:t>The suggestion travels in the URL fragment, never to a server. The sender reviews and sends.</a:t>
+              <a:t>It draws a live box on every plate; ML Kit then reads the crop. Honest limit: the training photos are mostly not Indian, so the next step is fine-tuning on Indian plates.</a:t>
             </a:r>
           </a:p>
         </p:txBody>
@@ -4403,7 +4609,7 @@
               </a:defRPr>
             </a:pPr>
             <a:r>
-              <a:t>On-device AI: the language bridge</a:t>
+              <a:t>On-device AI: understand the situation</a:t>
             </a:r>
           </a:p>
         </p:txBody>
@@ -4441,7 +4647,7 @@
               </a:defRPr>
             </a:pPr>
             <a:r>
-              <a:t>Detect the language of a stranger's message and translate it on the phone (English, Hindi, Kannada, Tamil).</a:t>
+              <a:t>Photograph the problem; the phone labels the scene on-device.</a:t>
             </a:r>
           </a:p>
           <a:p>
@@ -4456,7 +4662,7 @@
               </a:defRPr>
             </a:pPr>
             <a:r>
-              <a:t>Owners can dictate replies by voice in their own language.</a:t>
+              <a:t>On a clear sign (a wreck, a tow truck, a gate in frame) it suggests the reason, drafts the message and flags urgency. Otherwise it leaves the choice to you.</a:t>
             </a:r>
           </a:p>
           <a:p>
@@ -4471,7 +4677,7 @@
               </a:defRPr>
             </a:pPr>
             <a:r>
-              <a:t>Language packs download once; after that it works offline.</a:t>
+              <a:t>The suggestion travels in the URL fragment, never to a server. The sender reviews and sends.</a:t>
             </a:r>
           </a:p>
         </p:txBody>
@@ -4570,7 +4776,7 @@
               </a:defRPr>
             </a:pPr>
             <a:r>
-              <a:t>BEYOND THE FIRST ALERT</a:t>
+              <a:t>BUILT FOR IQOO</a:t>
             </a:r>
           </a:p>
         </p:txBody>
@@ -4608,7 +4814,7 @@
               </a:defRPr>
             </a:pPr>
             <a:r>
-              <a:t>Reasons to open it every week</a:t>
+              <a:t>On-device AI: the language bridge</a:t>
             </a:r>
           </a:p>
         </p:txBody>
@@ -4646,7 +4852,7 @@
               </a:defRPr>
             </a:pPr>
             <a:r>
-              <a:t>Parking memory, fuel and service log with a PDF history for resale.</a:t>
+              <a:t>Detect the language of a stranger's message and translate it on the phone (English, Hindi, Kannada, Tamil).</a:t>
             </a:r>
           </a:p>
           <a:p>
@@ -4661,7 +4867,7 @@
               </a:defRPr>
             </a:pPr>
             <a:r>
-              <a:t>Family sharing, crash detection with a 15-second cancel, one-tap 112 and SOS.</a:t>
+              <a:t>Owners can dictate replies by voice in their own language.</a:t>
             </a:r>
           </a:p>
           <a:p>
@@ -4676,7 +4882,7 @@
               </a:defRPr>
             </a:pPr>
             <a:r>
-              <a:t>Live trip sharing, renewals, housing-society notice board.</a:t>
+              <a:t>Language packs download once; after that it works offline.</a:t>
             </a:r>
           </a:p>
         </p:txBody>
@@ -4775,7 +4981,7 @@
               </a:defRPr>
             </a:pPr>
             <a:r>
-              <a:t>TRUST</a:t>
+              <a:t>BEYOND THE FIRST ALERT</a:t>
             </a:r>
           </a:p>
         </p:txBody>
@@ -4813,7 +5019,7 @@
               </a:defRPr>
             </a:pPr>
             <a:r>
-              <a:t>Privacy by construction</a:t>
+              <a:t>Reasons to open it every week</a:t>
             </a:r>
           </a:p>
         </p:txBody>
@@ -4851,7 +5057,7 @@
               </a:defRPr>
             </a:pPr>
             <a:r>
-              <a:t>Strangers never touch the database: one edge function checks the plate, rate-limits and hashes IPs.</a:t>
+              <a:t>Parking memory, fuel and service log with a PDF history for resale.</a:t>
             </a:r>
           </a:p>
           <a:p>
@@ -4866,7 +5072,7 @@
               </a:defRPr>
             </a:pPr>
             <a:r>
-              <a:t>Colour, make and model only. No name, number or address, ever.</a:t>
+              <a:t>Family sharing, crash detection with a 15-second cancel, one-tap 112 and SOS.</a:t>
             </a:r>
           </a:p>
           <a:p>
@@ -4881,7 +5087,7 @@
               </a:defRPr>
             </a:pPr>
             <a:r>
-              <a:t>Personal logs stay on the phone. In-app account deletion removes everything.</a:t>
+              <a:t>Live trip sharing, renewals, housing-society notice board.</a:t>
             </a:r>
           </a:p>
         </p:txBody>
@@ -4980,7 +5186,7 @@
               </a:defRPr>
             </a:pPr>
             <a:r>
-              <a:t>PROOF</a:t>
+              <a:t>TRUST</a:t>
             </a:r>
           </a:p>
         </p:txBody>
@@ -5018,7 +5224,7 @@
               </a:defRPr>
             </a:pPr>
             <a:r>
-              <a:t>Free to run, tested to trust</a:t>
+              <a:t>Privacy by construction</a:t>
             </a:r>
           </a:p>
         </p:txBody>
@@ -5056,7 +5262,7 @@
               </a:defRPr>
             </a:pPr>
             <a:r>
-              <a:t>Rs 0 per month on free tiers (Supabase, FCM, Vercel).</a:t>
+              <a:t>Strangers never touch the database: one edge function checks the plate, rate-limits and hashes IPs.</a:t>
             </a:r>
           </a:p>
           <a:p>
@@ -5071,7 +5277,7 @@
               </a:defRPr>
             </a:pPr>
             <a:r>
-              <a:t>119 backend end-to-end checks and 49 app tests and 3 on-device ML checks; CI on every push.</a:t>
+              <a:t>Colour, make and model only. No name, number or address, ever.</a:t>
             </a:r>
           </a:p>
           <a:p>
@@ -5086,7 +5292,7 @@
               </a:defRPr>
             </a:pPr>
             <a:r>
-              <a:t>English, Hindi, Kannada and Tamil across the app, scan page and trip page.</a:t>
+              <a:t>Personal logs stay on the phone. In-app account deletion removes everything.</a:t>
             </a:r>
           </a:p>
         </p:txBody>

</xml_diff>

<commit_message>
Deck: three slides for our own models with the real measured results
</commit_message>
<xml_diff>
--- a/docs/connect-iqoo-deck.pptx
+++ b/docs/connect-iqoo-deck.pptx
@@ -16,6 +16,8 @@
     <p:sldId id="264" r:id="rId15"/>
     <p:sldId id="265" r:id="rId16"/>
     <p:sldId id="266" r:id="rId17"/>
+    <p:sldId id="267" r:id="rId18"/>
+    <p:sldId id="268" r:id="rId19"/>
   </p:sldIdLst>
   <p:sldSz cx="12191695" cy="6858000" type="screen4x3"/>
   <p:notesSz cx="6858000" cy="9144000"/>
@@ -3326,7 +3328,7 @@
               </a:defRPr>
             </a:pPr>
             <a:r>
-              <a:t>PROOF</a:t>
+              <a:t>BEYOND THE FIRST ALERT</a:t>
             </a:r>
           </a:p>
         </p:txBody>
@@ -3364,7 +3366,7 @@
               </a:defRPr>
             </a:pPr>
             <a:r>
-              <a:t>Free to run, tested to trust</a:t>
+              <a:t>Reasons to open it every week</a:t>
             </a:r>
           </a:p>
         </p:txBody>
@@ -3402,7 +3404,7 @@
               </a:defRPr>
             </a:pPr>
             <a:r>
-              <a:t>Rs 0 per month on free tiers (Supabase, FCM, Vercel).</a:t>
+              <a:t>Parking memory, fuel and service log with a PDF history for resale.</a:t>
             </a:r>
           </a:p>
           <a:p>
@@ -3417,7 +3419,7 @@
               </a:defRPr>
             </a:pPr>
             <a:r>
-              <a:t>119 backend end-to-end checks and 49 app tests and 3 on-device ML checks; CI on every push.</a:t>
+              <a:t>Family sharing, crash detection with a 15-second cancel, one-tap 112 and SOS.</a:t>
             </a:r>
           </a:p>
           <a:p>
@@ -3432,7 +3434,7 @@
               </a:defRPr>
             </a:pPr>
             <a:r>
-              <a:t>English, Hindi, Kannada and Tamil across the app, scan page and trip page.</a:t>
+              <a:t>Live trip sharing, renewals, housing-society notice board.</a:t>
             </a:r>
           </a:p>
         </p:txBody>
@@ -3470,6 +3472,416 @@
             <a:avLst/>
           </a:prstGeom>
           <a:solidFill>
+            <a:srgbClr val="EEEDF8"/>
+          </a:solidFill>
+          <a:ln>
+            <a:noFill/>
+          </a:ln>
+        </p:spPr>
+        <p:style>
+          <a:lnRef idx="1">
+            <a:schemeClr val="accent1"/>
+          </a:lnRef>
+          <a:fillRef idx="3">
+            <a:schemeClr val="accent1"/>
+          </a:fillRef>
+          <a:effectRef idx="2">
+            <a:schemeClr val="accent1"/>
+          </a:effectRef>
+          <a:fontRef idx="minor">
+            <a:schemeClr val="lt1"/>
+          </a:fontRef>
+        </p:style>
+        <p:txBody>
+          <a:bodyPr rtlCol="0" anchor="ctr"/>
+          <a:lstStyle/>
+          <a:p>
+            <a:pPr algn="ctr"/>
+          </a:p>
+        </p:txBody>
+      </p:sp>
+      <p:sp>
+        <p:nvSpPr>
+          <p:cNvPr id="3" name="TextBox 2"/>
+          <p:cNvSpPr txBox="1"/>
+          <p:nvPr/>
+        </p:nvSpPr>
+        <p:spPr>
+          <a:xfrm>
+            <a:off x="731520" y="548640"/>
+            <a:ext cx="10058400" cy="365760"/>
+          </a:xfrm>
+          <a:prstGeom prst="rect">
+            <a:avLst/>
+          </a:prstGeom>
+          <a:noFill/>
+        </p:spPr>
+        <p:txBody>
+          <a:bodyPr wrap="square">
+            <a:spAutoFit/>
+          </a:bodyPr>
+          <a:lstStyle/>
+          <a:p>
+            <a:pPr>
+              <a:spcAft>
+                <a:spcPts val="1000"/>
+              </a:spcAft>
+              <a:defRPr sz="1400" b="1">
+                <a:solidFill>
+                  <a:srgbClr val="5A45C9"/>
+                </a:solidFill>
+              </a:defRPr>
+            </a:pPr>
+            <a:r>
+              <a:t>TRUST</a:t>
+            </a:r>
+          </a:p>
+        </p:txBody>
+      </p:sp>
+      <p:sp>
+        <p:nvSpPr>
+          <p:cNvPr id="4" name="TextBox 3"/>
+          <p:cNvSpPr txBox="1"/>
+          <p:nvPr/>
+        </p:nvSpPr>
+        <p:spPr>
+          <a:xfrm>
+            <a:off x="731520" y="914400"/>
+            <a:ext cx="10698480" cy="1280160"/>
+          </a:xfrm>
+          <a:prstGeom prst="rect">
+            <a:avLst/>
+          </a:prstGeom>
+          <a:noFill/>
+        </p:spPr>
+        <p:txBody>
+          <a:bodyPr wrap="square">
+            <a:spAutoFit/>
+          </a:bodyPr>
+          <a:lstStyle/>
+          <a:p>
+            <a:pPr>
+              <a:spcAft>
+                <a:spcPts val="1000"/>
+              </a:spcAft>
+              <a:defRPr sz="4000" b="1">
+                <a:solidFill>
+                  <a:srgbClr val="171335"/>
+                </a:solidFill>
+              </a:defRPr>
+            </a:pPr>
+            <a:r>
+              <a:t>Privacy by construction</a:t>
+            </a:r>
+          </a:p>
+        </p:txBody>
+      </p:sp>
+      <p:sp>
+        <p:nvSpPr>
+          <p:cNvPr id="5" name="TextBox 4"/>
+          <p:cNvSpPr txBox="1"/>
+          <p:nvPr/>
+        </p:nvSpPr>
+        <p:spPr>
+          <a:xfrm>
+            <a:off x="731520" y="2468880"/>
+            <a:ext cx="10515600" cy="3931920"/>
+          </a:xfrm>
+          <a:prstGeom prst="rect">
+            <a:avLst/>
+          </a:prstGeom>
+          <a:noFill/>
+        </p:spPr>
+        <p:txBody>
+          <a:bodyPr wrap="square">
+            <a:spAutoFit/>
+          </a:bodyPr>
+          <a:lstStyle/>
+          <a:p>
+            <a:pPr>
+              <a:spcAft>
+                <a:spcPts val="1000"/>
+              </a:spcAft>
+              <a:defRPr sz="2200" b="0">
+                <a:solidFill>
+                  <a:srgbClr val="575279"/>
+                </a:solidFill>
+              </a:defRPr>
+            </a:pPr>
+            <a:r>
+              <a:t>Strangers never touch the database: one edge function checks the plate, rate-limits and hashes IPs.</a:t>
+            </a:r>
+          </a:p>
+          <a:p>
+            <a:pPr>
+              <a:spcAft>
+                <a:spcPts val="1000"/>
+              </a:spcAft>
+              <a:defRPr sz="2200" b="0">
+                <a:solidFill>
+                  <a:srgbClr val="575279"/>
+                </a:solidFill>
+              </a:defRPr>
+            </a:pPr>
+            <a:r>
+              <a:t>Colour, make and model only. No name, number or address, ever.</a:t>
+            </a:r>
+          </a:p>
+          <a:p>
+            <a:pPr>
+              <a:spcAft>
+                <a:spcPts val="1000"/>
+              </a:spcAft>
+              <a:defRPr sz="2200" b="0">
+                <a:solidFill>
+                  <a:srgbClr val="575279"/>
+                </a:solidFill>
+              </a:defRPr>
+            </a:pPr>
+            <a:r>
+              <a:t>Personal logs stay on the phone. In-app account deletion removes everything.</a:t>
+            </a:r>
+          </a:p>
+        </p:txBody>
+      </p:sp>
+    </p:spTree>
+  </p:cSld>
+  <p:clrMapOvr>
+    <a:masterClrMapping/>
+  </p:clrMapOvr>
+</p:sld>
+</file>
+
+<file path=ppt/slides/slide12.xml><?xml version="1.0" encoding="utf-8"?>
+<p:sld xmlns:a="http://schemas.openxmlformats.org/drawingml/2006/main" xmlns:p="http://schemas.openxmlformats.org/presentationml/2006/main" xmlns:r="http://schemas.openxmlformats.org/officeDocument/2006/relationships">
+  <p:cSld>
+    <p:spTree>
+      <p:nvGrpSpPr>
+        <p:cNvPr id="1" name=""/>
+        <p:cNvGrpSpPr/>
+        <p:nvPr/>
+      </p:nvGrpSpPr>
+      <p:grpSpPr/>
+      <p:sp>
+        <p:nvSpPr>
+          <p:cNvPr id="2" name="Rectangle 1"/>
+          <p:cNvSpPr/>
+          <p:nvPr/>
+        </p:nvSpPr>
+        <p:spPr>
+          <a:xfrm>
+            <a:off x="0" y="0"/>
+            <a:ext cx="12191695" cy="6858000"/>
+          </a:xfrm>
+          <a:prstGeom prst="rect">
+            <a:avLst/>
+          </a:prstGeom>
+          <a:solidFill>
+            <a:srgbClr val="EEEDF8"/>
+          </a:solidFill>
+          <a:ln>
+            <a:noFill/>
+          </a:ln>
+        </p:spPr>
+        <p:style>
+          <a:lnRef idx="1">
+            <a:schemeClr val="accent1"/>
+          </a:lnRef>
+          <a:fillRef idx="3">
+            <a:schemeClr val="accent1"/>
+          </a:fillRef>
+          <a:effectRef idx="2">
+            <a:schemeClr val="accent1"/>
+          </a:effectRef>
+          <a:fontRef idx="minor">
+            <a:schemeClr val="lt1"/>
+          </a:fontRef>
+        </p:style>
+        <p:txBody>
+          <a:bodyPr rtlCol="0" anchor="ctr"/>
+          <a:lstStyle/>
+          <a:p>
+            <a:pPr algn="ctr"/>
+          </a:p>
+        </p:txBody>
+      </p:sp>
+      <p:sp>
+        <p:nvSpPr>
+          <p:cNvPr id="3" name="TextBox 2"/>
+          <p:cNvSpPr txBox="1"/>
+          <p:nvPr/>
+        </p:nvSpPr>
+        <p:spPr>
+          <a:xfrm>
+            <a:off x="731520" y="548640"/>
+            <a:ext cx="10058400" cy="365760"/>
+          </a:xfrm>
+          <a:prstGeom prst="rect">
+            <a:avLst/>
+          </a:prstGeom>
+          <a:noFill/>
+        </p:spPr>
+        <p:txBody>
+          <a:bodyPr wrap="square">
+            <a:spAutoFit/>
+          </a:bodyPr>
+          <a:lstStyle/>
+          <a:p>
+            <a:pPr>
+              <a:spcAft>
+                <a:spcPts val="1000"/>
+              </a:spcAft>
+              <a:defRPr sz="1400" b="1">
+                <a:solidFill>
+                  <a:srgbClr val="5A45C9"/>
+                </a:solidFill>
+              </a:defRPr>
+            </a:pPr>
+            <a:r>
+              <a:t>PROOF</a:t>
+            </a:r>
+          </a:p>
+        </p:txBody>
+      </p:sp>
+      <p:sp>
+        <p:nvSpPr>
+          <p:cNvPr id="4" name="TextBox 3"/>
+          <p:cNvSpPr txBox="1"/>
+          <p:nvPr/>
+        </p:nvSpPr>
+        <p:spPr>
+          <a:xfrm>
+            <a:off x="731520" y="914400"/>
+            <a:ext cx="10698480" cy="1280160"/>
+          </a:xfrm>
+          <a:prstGeom prst="rect">
+            <a:avLst/>
+          </a:prstGeom>
+          <a:noFill/>
+        </p:spPr>
+        <p:txBody>
+          <a:bodyPr wrap="square">
+            <a:spAutoFit/>
+          </a:bodyPr>
+          <a:lstStyle/>
+          <a:p>
+            <a:pPr>
+              <a:spcAft>
+                <a:spcPts val="1000"/>
+              </a:spcAft>
+              <a:defRPr sz="4000" b="1">
+                <a:solidFill>
+                  <a:srgbClr val="171335"/>
+                </a:solidFill>
+              </a:defRPr>
+            </a:pPr>
+            <a:r>
+              <a:t>Free to run, tested to trust</a:t>
+            </a:r>
+          </a:p>
+        </p:txBody>
+      </p:sp>
+      <p:sp>
+        <p:nvSpPr>
+          <p:cNvPr id="5" name="TextBox 4"/>
+          <p:cNvSpPr txBox="1"/>
+          <p:nvPr/>
+        </p:nvSpPr>
+        <p:spPr>
+          <a:xfrm>
+            <a:off x="731520" y="2468880"/>
+            <a:ext cx="10515600" cy="3931920"/>
+          </a:xfrm>
+          <a:prstGeom prst="rect">
+            <a:avLst/>
+          </a:prstGeom>
+          <a:noFill/>
+        </p:spPr>
+        <p:txBody>
+          <a:bodyPr wrap="square">
+            <a:spAutoFit/>
+          </a:bodyPr>
+          <a:lstStyle/>
+          <a:p>
+            <a:pPr>
+              <a:spcAft>
+                <a:spcPts val="1000"/>
+              </a:spcAft>
+              <a:defRPr sz="2200" b="0">
+                <a:solidFill>
+                  <a:srgbClr val="575279"/>
+                </a:solidFill>
+              </a:defRPr>
+            </a:pPr>
+            <a:r>
+              <a:t>Rs 0 per month on free tiers (Supabase, FCM, Vercel).</a:t>
+            </a:r>
+          </a:p>
+          <a:p>
+            <a:pPr>
+              <a:spcAft>
+                <a:spcPts val="1000"/>
+              </a:spcAft>
+              <a:defRPr sz="2200" b="0">
+                <a:solidFill>
+                  <a:srgbClr val="575279"/>
+                </a:solidFill>
+              </a:defRPr>
+            </a:pPr>
+            <a:r>
+              <a:t>119 backend end-to-end checks and 87 app tests and on-device ML checks; CI on every push.</a:t>
+            </a:r>
+          </a:p>
+          <a:p>
+            <a:pPr>
+              <a:spcAft>
+                <a:spcPts val="1000"/>
+              </a:spcAft>
+              <a:defRPr sz="2200" b="0">
+                <a:solidFill>
+                  <a:srgbClr val="575279"/>
+                </a:solidFill>
+              </a:defRPr>
+            </a:pPr>
+            <a:r>
+              <a:t>English, Hindi, Kannada and Tamil across the app, scan page and trip page.</a:t>
+            </a:r>
+          </a:p>
+        </p:txBody>
+      </p:sp>
+    </p:spTree>
+  </p:cSld>
+  <p:clrMapOvr>
+    <a:masterClrMapping/>
+  </p:clrMapOvr>
+</p:sld>
+</file>
+
+<file path=ppt/slides/slide13.xml><?xml version="1.0" encoding="utf-8"?>
+<p:sld xmlns:a="http://schemas.openxmlformats.org/drawingml/2006/main" xmlns:p="http://schemas.openxmlformats.org/presentationml/2006/main" xmlns:r="http://schemas.openxmlformats.org/officeDocument/2006/relationships">
+  <p:cSld>
+    <p:spTree>
+      <p:nvGrpSpPr>
+        <p:cNvPr id="1" name=""/>
+        <p:cNvGrpSpPr/>
+        <p:nvPr/>
+      </p:nvGrpSpPr>
+      <p:grpSpPr/>
+      <p:sp>
+        <p:nvSpPr>
+          <p:cNvPr id="2" name="Rectangle 1"/>
+          <p:cNvSpPr/>
+          <p:nvPr/>
+        </p:nvSpPr>
+        <p:spPr>
+          <a:xfrm>
+            <a:off x="0" y="0"/>
+            <a:ext cx="12191695" cy="6858000"/>
+          </a:xfrm>
+          <a:prstGeom prst="rect">
+            <a:avLst/>
+          </a:prstGeom>
+          <a:solidFill>
             <a:srgbClr val="171335"/>
           </a:solidFill>
           <a:ln>
@@ -4404,7 +4816,7 @@
               </a:defRPr>
             </a:pPr>
             <a:r>
-              <a:t>Our own ML model: a plate detector</a:t>
+              <a:t>Our own ML, 1 of 3: the plate detector</a:t>
             </a:r>
           </a:p>
         </p:txBody>
@@ -4442,7 +4854,7 @@
               </a:defRPr>
             </a:pPr>
             <a:r>
-              <a:t>YOLO11n we trained on 8,823 plate photos in 11 minutes on a laptop GPU. 2.6 M parameters, 10 MB, runs on the phone with ONNX Runtime.</a:t>
+              <a:t>A YOLO11n we trained on 8,823 plate photos, then fine-tuned on Indian close-ups. 4.3 MB after INT8, runs on the phone with ONNX Runtime.</a:t>
             </a:r>
           </a:p>
           <a:p>
@@ -4457,7 +4869,7 @@
               </a:defRPr>
             </a:pPr>
             <a:r>
-              <a:t>Held-out test: mAP50 0.991, precision 0.992, recall 0.977 (882 photos). About 80-130 ms a frame on an emulator CPU.</a:t>
+              <a:t>Honest test: 47 real Indian phone photos it never saw. mAP50 0.73, up from 0.64 before fine-tuning. On its own non-Indian test set: 0.98.</a:t>
             </a:r>
           </a:p>
           <a:p>
@@ -4472,7 +4884,7 @@
               </a:defRPr>
             </a:pPr>
             <a:r>
-              <a:t>It draws a live box on every plate; ML Kit then reads the crop. Honest limit: the training photos are mostly not Indian, so the next step is fine-tuning on Indian plates.</a:t>
+              <a:t>INT8 cost nothing in accuracy and made it 1.6x faster (keeping the detection head in float; plain INT8 broke it).</a:t>
             </a:r>
           </a:p>
         </p:txBody>
@@ -4609,7 +5021,7 @@
               </a:defRPr>
             </a:pPr>
             <a:r>
-              <a:t>On-device AI: understand the situation</a:t>
+              <a:t>Our own ML, 2 of 3: the plate reader</a:t>
             </a:r>
           </a:p>
         </p:txBody>
@@ -4647,7 +5059,7 @@
               </a:defRPr>
             </a:pPr>
             <a:r>
-              <a:t>Photograph the problem; the phone labels the scene on-device.</a:t>
+              <a:t>A small CRNN (3.4 MB) trained on 360,000 synthetic Indian plates plus real crops. We beat ML Kit on 150 real Indian plates it never saw: 60.7% exact against 49.3% (same repair rules).</a:t>
             </a:r>
           </a:p>
           <a:p>
@@ -4662,7 +5074,7 @@
               </a:defRPr>
             </a:pPr>
             <a:r>
-              <a:t>On a clear sign (a wreck, a tow truck, a gate in frame) it suggests the reason, drafts the message and flags urgency. Otherwise it leaves the choice to you.</a:t>
+              <a:t>The app tries ours first and shows both answers: the right plate is among them 73% of the time.</a:t>
             </a:r>
           </a:p>
           <a:p>
@@ -4677,7 +5089,7 @@
               </a:defRPr>
             </a:pPr>
             <a:r>
-              <a:t>The suggestion travels in the URL fragment, never to a server. The sender reviews and sends.</a:t>
+              <a:t>Honest limits: small test, ML Kit is slightly more precise when it answers, so the app uses both.</a:t>
             </a:r>
           </a:p>
         </p:txBody>
@@ -4814,7 +5226,7 @@
               </a:defRPr>
             </a:pPr>
             <a:r>
-              <a:t>On-device AI: the language bridge</a:t>
+              <a:t>Our own ML, 3 of 3: damage and a rough cost</a:t>
             </a:r>
           </a:p>
         </p:txBody>
@@ -4852,7 +5264,7 @@
               </a:defRPr>
             </a:pPr>
             <a:r>
-              <a:t>Detect the language of a stranger's message and translate it on the phone (English, Hindi, Kannada, Tamil).</a:t>
+              <a:t>Photograph a dent, scratch or crack: a model on the phone marks it and gives a rough rupee range for that car, plus an evidence PDF for the owner or insurer.</a:t>
             </a:r>
           </a:p>
           <a:p>
@@ -4867,7 +5279,7 @@
               </a:defRPr>
             </a:pPr>
             <a:r>
-              <a:t>Owners can dictate replies by voice in their own language.</a:t>
+              <a:t>Trained on 10,000 labelled photos. Honest scores: shattered glass 0.66, crack 0.32, dent 0.27, scratch 0.21 (mAP50, 0.37 overall). Only four classes are reliable.</a:t>
             </a:r>
           </a:p>
           <a:p>
@@ -4882,7 +5294,7 @@
               </a:defRPr>
             </a:pPr>
             <a:r>
-              <a:t>Language packs download once; after that it works offline.</a:t>
+              <a:t>The cost is a hand-set range scaled by car size, brand and damaged area, shown with a get-a-quote note. It is an estimate, not a quote.</a:t>
             </a:r>
           </a:p>
         </p:txBody>
@@ -4981,7 +5393,7 @@
               </a:defRPr>
             </a:pPr>
             <a:r>
-              <a:t>BEYOND THE FIRST ALERT</a:t>
+              <a:t>BUILT FOR IQOO</a:t>
             </a:r>
           </a:p>
         </p:txBody>
@@ -5019,7 +5431,7 @@
               </a:defRPr>
             </a:pPr>
             <a:r>
-              <a:t>Reasons to open it every week</a:t>
+              <a:t>On-device AI: understand the situation</a:t>
             </a:r>
           </a:p>
         </p:txBody>
@@ -5057,7 +5469,7 @@
               </a:defRPr>
             </a:pPr>
             <a:r>
-              <a:t>Parking memory, fuel and service log with a PDF history for resale.</a:t>
+              <a:t>Photograph the problem; the phone labels the scene on-device.</a:t>
             </a:r>
           </a:p>
           <a:p>
@@ -5072,7 +5484,7 @@
               </a:defRPr>
             </a:pPr>
             <a:r>
-              <a:t>Family sharing, crash detection with a 15-second cancel, one-tap 112 and SOS.</a:t>
+              <a:t>On a clear sign (a wreck, a tow truck, a gate in frame) it suggests the reason, drafts the message and flags urgency. Otherwise it leaves the choice to you.</a:t>
             </a:r>
           </a:p>
           <a:p>
@@ -5087,7 +5499,7 @@
               </a:defRPr>
             </a:pPr>
             <a:r>
-              <a:t>Live trip sharing, renewals, housing-society notice board.</a:t>
+              <a:t>The suggestion travels in the URL fragment, never to a server. The sender reviews and sends.</a:t>
             </a:r>
           </a:p>
         </p:txBody>
@@ -5186,7 +5598,7 @@
               </a:defRPr>
             </a:pPr>
             <a:r>
-              <a:t>TRUST</a:t>
+              <a:t>BUILT FOR IQOO</a:t>
             </a:r>
           </a:p>
         </p:txBody>
@@ -5224,7 +5636,7 @@
               </a:defRPr>
             </a:pPr>
             <a:r>
-              <a:t>Privacy by construction</a:t>
+              <a:t>On-device AI: the language bridge</a:t>
             </a:r>
           </a:p>
         </p:txBody>
@@ -5262,7 +5674,7 @@
               </a:defRPr>
             </a:pPr>
             <a:r>
-              <a:t>Strangers never touch the database: one edge function checks the plate, rate-limits and hashes IPs.</a:t>
+              <a:t>Detect the language of a stranger's message and translate it on the phone (English, Hindi, Kannada, Tamil).</a:t>
             </a:r>
           </a:p>
           <a:p>
@@ -5277,7 +5689,7 @@
               </a:defRPr>
             </a:pPr>
             <a:r>
-              <a:t>Colour, make and model only. No name, number or address, ever.</a:t>
+              <a:t>Owners can dictate replies by voice in their own language.</a:t>
             </a:r>
           </a:p>
           <a:p>
@@ -5292,7 +5704,7 @@
               </a:defRPr>
             </a:pPr>
             <a:r>
-              <a:t>Personal logs stay on the phone. In-app account deletion removes everything.</a:t>
+              <a:t>Language packs download once; after that it works offline.</a:t>
             </a:r>
           </a:p>
         </p:txBody>

</xml_diff>